<commit_message>
Use LR1 five-year average TCE in the payback sensitivity
Replace the rough 2025-level TCE assumption (35,000 $/day) with the LR1
five-year realised average of about 33,000 $/day (TORM 2021-25, Hafnia),
which is the benchmark that fits a 75k DWT hull; the Aframax average would
overstate it. Payback rows become 0.81 / 3.4 / 8.3 years. Note on the slide
that TD9 fell from WS373 to WS197 (39,600 $/day) one week after the report's
reference date, and cite the contract-price ranges by yard country.

Q&A document: update the payback answers with the verified 2026 TD9 timeline
(April Hormuz peak, late-July and late-August prints), add a question on the
inconsistent inputs between the rotor-sail and economics sections of the
report (methanol price, operating days, route distance), and add the
formula lineage for the build-cost estimate.

Co-Authored-By: Claude Fable 5.1 <noreply@anthropic.com>
Claude-Session: https://claude.ai/code/session_01KYxRjEufxoxoFhSS4GKPUN
</commit_message>
<xml_diff>
--- a/contest/presentation/2026_74K_발표자료_10분.pptx
+++ b/contest/presentation/2026_74K_발표자료_10분.pptx
@@ -1809,7 +1809,7 @@
           <a:p>
             <a:r>
               <a:rPr lang="en-US" dirty="0"/>
-              <a:t>경제성입니다. 건조비는 약 2,666만 달러입니다. 회수기간은 2026년 8월 시황 기준 0.81년이지만, 2025년 평균 운임과 시장 신조선가를 적용하면 약 8년으로 시황에 크게 좌우됩니다. 정리하면 본 설계선은 국제 규정과 선급 요건을 모두 만족하면서, 메탄올 이중연료와 축발전기, 로터 세일로 EEDI Phase 3까지 만족시킨 74K급 원유운반선입니다.</a:t>
+              <a:t>경제성입니다. 건조비는 약 2,666만 달러입니다. 회수기간은 2026년 8월 시황 기준 0.81년이지만, LR1 5년 평균 운임과 시장 신조선가를 적용하면 약 8년으로 시황에 크게 좌우됩니다. 정리하면 본 설계선은 국제 규정과 선급 요건을 모두 만족하면서, 메탄올 이중연료와 축발전기, 로터 세일로 EEDI Phase 3까지 만족시킨 74K급 원유운반선입니다.</a:t>
             </a:r>
             <a:endParaRPr lang="en-US" dirty="0"/>
           </a:p>
@@ -15960,7 +15960,7 @@
         <p:spPr>
           <a:xfrm>
             <a:off x="548640" y="4315968"/>
-            <a:ext cx="5212080" cy="713232"/>
+            <a:ext cx="5212080" cy="658368"/>
           </a:xfrm>
           <a:prstGeom prst="rect">
             <a:avLst/>
@@ -15980,7 +15980,7 @@
               <a:buChar char="▪"/>
             </a:pPr>
             <a:r>
-              <a:rPr lang="en-US" sz="1050" dirty="0">
+              <a:rPr lang="en-US" sz="1000" dirty="0">
                 <a:solidFill>
                   <a:srgbClr val="262626"/>
                 </a:solidFill>
@@ -15988,9 +15988,9 @@
                 <a:ea typeface="Malgun Gothic" pitchFamily="34" charset="-122"/>
                 <a:cs typeface="Malgun Gothic" pitchFamily="34" charset="-120"/>
               </a:rPr>
-              <a:t>연간 355일 운항, 왕복 30.5 항차 (항해 4.81일 + 정박 1일) · 운용비 USD 3.81 M/년</a:t>
+              <a:t>연간 355일 운항 · 왕복 30.5항차 (항해 4.81일 + 정박 1일) · 운용비 3.81 M $/년</a:t>
             </a:r>
-            <a:endParaRPr lang="en-US" sz="1050" dirty="0"/>
+            <a:endParaRPr lang="en-US" sz="1000" dirty="0"/>
           </a:p>
           <a:p>
             <a:pPr marL="165100" indent="-165100">
@@ -16001,7 +16001,7 @@
               <a:buChar char="▪"/>
             </a:pPr>
             <a:r>
-              <a:rPr lang="en-US" sz="1050" dirty="0">
+              <a:rPr lang="en-US" sz="1000" dirty="0">
                 <a:solidFill>
                   <a:srgbClr val="262626"/>
                 </a:solidFill>
@@ -16009,9 +16009,9 @@
                 <a:ea typeface="Malgun Gothic" pitchFamily="34" charset="-122"/>
                 <a:cs typeface="Malgun Gothic" pitchFamily="34" charset="-120"/>
               </a:rPr>
-              <a:t>TD9 = WS373 (2026.8.21, Baltic) → Round Voyage TCE ≈ USD 104,000/day</a:t>
+              <a:t>TD9 WS373 (8.21) → TCE ≈ 104,000 $/day · 일주일 뒤 (8.28) WS197 → 39,600</a:t>
             </a:r>
-            <a:endParaRPr lang="en-US" sz="1050" dirty="0"/>
+            <a:endParaRPr lang="en-US" sz="1000" dirty="0"/>
           </a:p>
         </p:txBody>
       </p:sp>
@@ -16335,7 +16335,7 @@
                           <a:ea typeface="Malgun Gothic" pitchFamily="34" charset="-122"/>
                           <a:cs typeface="Malgun Gothic" pitchFamily="34" charset="-120"/>
                         </a:rPr>
-                        <a:t>보고서 기준 (2026.8 TD9 WS373)</a:t>
+                        <a:t>보고서 기준 (2026.8.21 TD9 WS373)</a:t>
                       </a:r>
                       <a:endParaRPr lang="en-US" sz="950" dirty="0">
                         <a:latin typeface="Malgun Gothic" charset="0"/>
@@ -16597,7 +16597,7 @@
                           <a:ea typeface="Malgun Gothic" pitchFamily="34" charset="-122"/>
                           <a:cs typeface="Malgun Gothic" pitchFamily="34" charset="-120"/>
                         </a:rPr>
-                        <a:t>2025년 시황 수준 적용</a:t>
+                        <a:t>LR1 5년 평균 운임 적용 (2021~25)</a:t>
                       </a:r>
                       <a:endParaRPr lang="en-US" sz="950" dirty="0">
                         <a:latin typeface="Malgun Gothic" charset="0"/>
@@ -16727,7 +16727,7 @@
                           <a:ea typeface="Malgun Gothic" pitchFamily="34" charset="-122"/>
                           <a:cs typeface="Malgun Gothic" pitchFamily="34" charset="-120"/>
                         </a:rPr>
-                        <a:t>≈ 35,000</a:t>
+                        <a:t>≈ 33,000</a:t>
                       </a:r>
                       <a:endParaRPr lang="en-US" sz="950" dirty="0">
                         <a:latin typeface="Malgun Gothic" charset="0"/>
@@ -16792,7 +16792,7 @@
                           <a:ea typeface="Malgun Gothic" pitchFamily="34" charset="-122"/>
                           <a:cs typeface="Malgun Gothic" pitchFamily="34" charset="-120"/>
                         </a:rPr>
-                        <a:t>3.1년</a:t>
+                        <a:t>3.4년</a:t>
                       </a:r>
                       <a:endParaRPr lang="en-US" sz="950" dirty="0">
                         <a:latin typeface="Malgun Gothic" charset="0"/>
@@ -16989,7 +16989,7 @@
                           <a:ea typeface="Malgun Gothic" pitchFamily="34" charset="-122"/>
                           <a:cs typeface="Malgun Gothic" pitchFamily="34" charset="-120"/>
                         </a:rPr>
-                        <a:t>≈ 35,000</a:t>
+                        <a:t>≈ 33,000</a:t>
                       </a:r>
                       <a:endParaRPr lang="en-US" sz="950" dirty="0">
                         <a:latin typeface="Malgun Gothic" charset="0"/>
@@ -17054,7 +17054,7 @@
                           <a:ea typeface="Malgun Gothic" pitchFamily="34" charset="-122"/>
                           <a:cs typeface="Malgun Gothic" pitchFamily="34" charset="-120"/>
                         </a:rPr>
-                        <a:t>7.7년</a:t>
+                        <a:t>8.3년</a:t>
                       </a:r>
                       <a:endParaRPr lang="en-US" sz="950" dirty="0">
                         <a:latin typeface="Malgun Gothic" charset="0"/>
@@ -17140,7 +17140,7 @@
                 <a:ea typeface="Malgun Gothic" pitchFamily="34" charset="-122"/>
                 <a:cs typeface="Malgun Gothic" pitchFamily="34" charset="-120"/>
               </a:rPr>
-              <a:t>출처 — TCE: Baltic TD9 주간 리포트 (2025년 1.5만~5만 $/day 변동) · 선가: 2024~26 LR1 계약 55~70 M + 메탄올 DF 10%</a:t>
+              <a:t>출처 — TCE: TORM·Hafnia LR1 실현 평균 2021~25 (3.1~3.3만 $/day) · 선가: LR1 계약 2024~26 중국 53~56 M · 한국 58~62 M, 메탄올 DF +10~11%</a:t>
             </a:r>
             <a:endParaRPr lang="en-US" sz="850" dirty="0"/>
           </a:p>

</xml_diff>

<commit_message>
Pre-empt rotor-sail and design-limit questions on slides 15-16
Slide 15: state that the saving survives netting out full rotor motor
power (345 kW -> >=380 kW, 4.6% of NCR), widen the field-data comparison to
the 6.5-9.1% range with a note on the 2% weak-wind case, and say the wind
input is measured route data. Slide 16: add a follow-up-work line
(cavitation check, rotor foundation and wind-load manoeuvring, loading-
manual-based still-water loads) so the team names its own limits first.
Script trimmed elsewhere to keep the deck under ten minutes.

Co-Authored-By: Claude Fable 5.1 <noreply@anthropic.com>
Claude-Session: https://claude.ai/code/session_01KYxRjEufxoxoFhSS4GKPUN
</commit_message>
<xml_diff>
--- a/contest/presentation/2026_74K_발표자료_10분.pptx
+++ b/contest/presentation/2026_74K_발표자료_10분.pptx
@@ -1369,7 +1369,7 @@
           <a:p>
             <a:r>
               <a:rPr lang="en-US" dirty="0"/>
-              <a:t>화물창은 MARPOL에 따라 윙탱크 폭과 이중저 높이를 각각 2.4미터로 한 이중선체이며, 총 용적 77,839세제곱미터입니다. 가상 기름 유출량과 슬롭탱크 용량도 규정 이내입니다. 건현은 ICLL 기준 허용 만재흘수 16.4미터로 스캔틀링 흘수를 상회하고, 의장수 2,559로 앵커와 체인을 결정했습니다. 가시거리도 전 흘수 조건에서 SOLAS 규정을 만족합니다.</a:t>
+              <a:t>화물창은 MARPOL에 따라 윙탱크 폭과 이중저 높이를 각각 2.4미터로 한 이중선체이며, 총 용적 77,839세제곱미터입니다. 가상 기름 유출량과 슬롭탱크 용량도 규정 이내입니다. 건현은 ICLL 기준 허용 만재흘수 16.4미터로 스캔틀링 흘수를 상회하고, 의장수 2,559로 앵커와 체인을 결정했습니다. 가시거리도 SOLAS 규정을 만족합니다.</a:t>
             </a:r>
             <a:endParaRPr lang="en-US" dirty="0"/>
           </a:p>
@@ -1457,7 +1457,7 @@
           <a:p>
             <a:r>
               <a:rPr lang="en-US" dirty="0"/>
-              <a:t>복원성입니다. 경하중량은 로터 세일을 포함해 14,724톤이며, 경하부터 만재까지 출항과 도착을 나눈 열 가지 적재조건을 검토했습니다. 모든 조건에서 IS Code 2008 비손상 기준과 종강도 허용치를 만족했습니다. 손상 복원성은 MARPOL 28규칙의 네 가지 손상 케이스 전부에서 잔존복원성 기준을 만족했습니다.</a:t>
+              <a:t>복원성입니다. 경하중량은 로터 세일을 포함해 14,724톤이며, 경하부터 만재까지 열 가지 적재조건을 검토했습니다. 모든 조건에서 IS Code 2008 비손상 기준과 종강도 허용치를 만족했습니다. 손상 복원성은 MARPOL 28규칙의 네 가지 손상 케이스 전부에서 잔존복원성 기준을 만족했습니다.</a:t>
             </a:r>
             <a:endParaRPr lang="en-US" dirty="0"/>
           </a:p>
@@ -1809,7 +1809,7 @@
           <a:p>
             <a:r>
               <a:rPr lang="en-US" dirty="0"/>
-              <a:t>경제성입니다. 건조비는 약 2,666만 달러입니다. 회수기간은 2026년 8월 시황 기준 0.81년이지만, LR1 5년 평균 운임과 시장 신조선가를 적용하면 약 8년으로 시황에 크게 좌우됩니다. 정리하면 본 설계선은 국제 규정과 선급 요건을 모두 만족하면서, 메탄올 이중연료와 축발전기, 로터 세일로 EEDI Phase 3까지 만족시킨 74K급 원유운반선입니다.</a:t>
+              <a:t>경제성입니다. 건조비는 약 2,666만 달러입니다. 회수기간은 2026년 8월 시황 기준 0.81년이지만, LR1 5년 평균 운임과 시장 신조선가를 적용하면 약 8년으로 시황에 크게 좌우됩니다. 정리하면 본 설계선은 국제 규정과 선급 요건을 모두 만족하면서, 메탄올 이중연료와 축발전기, 로터 세일로 EEDI Phase 3까지 만족시킨 74K급 원유운반선입니다. 캐비테이션 정량 검토와 로터 기초 해석은 후속 과제로 인식하고 있습니다.</a:t>
             </a:r>
             <a:endParaRPr lang="en-US" dirty="0"/>
           </a:p>
@@ -1985,7 +1985,7 @@
           <a:p>
             <a:r>
               <a:rPr lang="en-US" dirty="0"/>
-              <a:t>발표는 개념 설계부터 친환경까지 일곱 섹션 순으로 진행하겠습니다. 본 설계선의 핵심은 세 가지입니다. 첫째, 메탄올 이중연료입니다. LNG의 극저온 탱크 부담도, 저유황유의 세정장치도 없이 북미 배출규제해역 기준을 충족합니다. 둘째는 축발전기와 로터 세일을 통한 EEDI Phase 3 대응, 셋째는 단거리 TD9 항로 전략입니다.</a:t>
+              <a:t>발표는 개념 설계부터 친환경까지 일곱 섹션 순으로 진행하겠습니다. 핵심은 세 가지입니다. 첫째, 메탄올 이중연료입니다. LNG의 극저온 탱크 부담도, 저유황유의 세정장치도 없이 북미 배출규제해역 기준을 충족합니다. 둘째는 축발전기와 로터 세일을 통한 EEDI Phase 3 대응, 셋째는 단거리 TD9 항로 전략입니다.</a:t>
             </a:r>
             <a:endParaRPr lang="en-US" dirty="0"/>
           </a:p>
@@ -2073,7 +2073,7 @@
           <a:p>
             <a:r>
               <a:rPr lang="en-US" dirty="0"/>
-              <a:t>먼저 항로 선정입니다. 메탄올 벙커링이 가능하고 미국 최대 원유 수출항인 Corpus Christi를 공통 양하항으로 두고 세 항로를 비교했습니다. 콜롬비아 Conveñas 항로는 본선 규격과 일치하는 공인 운임지수 TD9가 있고 물동량도 가장 많습니다. 특히 편도 1,652해리 단거리라 메탄올 탱크가 만재 배수용적의 1.1퍼센트에 그쳐, 메탄올 추진의 약점인 적재량 손실을 해소합니다.</a:t>
+              <a:t>먼저 항로 선정입니다. 미국 최대 원유 수출항이자 메탄올 벙커링이 가능한 Corpus Christi를 공통 양하항으로 두고 세 항로를 비교했습니다. 콜롬비아 Conveñas 항로는 본선 규격과 일치하는 공인 운임지수 TD9가 있고 물동량도 가장 많습니다. 특히 편도 1,652해리 단거리라 메탄올 탱크가 만재 배수용적의 1.1퍼센트에 그쳐, 메탄올 추진의 약점인 적재량 손실을 해소합니다.</a:t>
             </a:r>
             <a:endParaRPr lang="en-US" dirty="0"/>
           </a:p>
@@ -2337,7 +2337,7 @@
           <a:p>
             <a:r>
               <a:rPr lang="en-US" dirty="0"/>
-              <a:t>저항은 Holtrop-Mennen 경험식을 CFD 및 ITTC 1978 실선 확장 결과와 비교해 보정계수 0.7315를 산출해 적용했습니다. 설계속도는 연료비와 항차수 증가에 따른 운임 수익을 함께 반영해, 연간 순이익이 최대가 되는 14.3노트로 선정했습니다. 이때 추정된 소요 마력은 약 9,650킬로와트입니다.</a:t>
+              <a:t>저항은 Holtrop-Mennen 경험식을 CFD 및 ITTC 1978 실선 확장 결과와 비교해 보정계수 0.7315를 산출해 적용했습니다. 설계속도는 연료비와 항차수 증가에 따른 운임 수익을 함께 반영해, 연간 순이익이 최대가 되는 14.3노트로 선정했습니다. 추정 소요 마력은 약 9,650킬로와트입니다.</a:t>
             </a:r>
             <a:endParaRPr lang="en-US" dirty="0"/>
           </a:p>
@@ -2425,7 +2425,7 @@
           <a:p>
             <a:r>
               <a:rPr lang="en-US" dirty="0"/>
-              <a:t>주기관은 메탄올 이중연료 운전이 가능한 5G60ME-C10.5-LGIM을 선정했습니다. 앞서 추정한 마력이 MEPC 최소추진마력 10,840킬로와트에 못 미쳐, 이를 상회하는 SMCR 10,890킬로와트로 결정했습니다. 질소산화물은 EGRTC로 대응하고, 축발전기 1,000킬로와트로 항해 중 보조기관 가동을 최소화했습니다. 이것만으로 EEDI가 4.411에서 3.580까지 내려갑니다.</a:t>
+              <a:t>주기관은 메탄올 이중연료 5G60ME-C10.5-LGIM을 선정했습니다. 앞서 추정한 마력이 MEPC 최소추진마력 10,840킬로와트에 못 미쳐, 이를 상회하는 SMCR 10,890킬로와트로 결정했습니다. 질소산화물은 EGRTC로 대응하고, 축발전기 1,000킬로와트로 항해 중 보조기관 가동을 최소화했습니다. 이것만으로 EEDI가 4.411에서 3.580까지 내려갑니다.</a:t>
             </a:r>
             <a:endParaRPr lang="en-US" dirty="0"/>
           </a:p>
@@ -2601,7 +2601,7 @@
           <a:p>
             <a:r>
               <a:rPr lang="en-US" dirty="0"/>
-              <a:t>타 면적은 네 가지 추정법의 결과 범위 안에서 42.83제곱미터로 정하고, 제작이 용이한 NACA 단면의 Semi-spade 타를 채택했습니다. 프로펠러·선체 간 간격도 기준을 만족합니다. 조종성능은 두 흘수 조건에서 선회, 지그재그, 크래시 스톱, 나선 시험을 수행했고 전 항목이 IMO 기준을 만족했습니다.</a:t>
+              <a:t>타 면적은 네 가지 추정법의 결과 범위 안에서 42.83제곱미터로 정하고, NACA 단면의 Semi-spade 타를 채택했습니다. 프로펠러·선체 간 간격도 기준을 만족합니다. 조종성능은 두 흘수 조건에서 선회, 지그재그, 크래시 스톱, 나선 시험을 수행했고 전 항목이 IMO 기준을 만족했습니다.</a:t>
             </a:r>
             <a:endParaRPr lang="en-US" dirty="0"/>
           </a:p>
@@ -14017,8 +14017,8 @@
         </p:nvSpPr>
         <p:spPr>
           <a:xfrm>
-            <a:off x="6263640" y="2880360"/>
-            <a:ext cx="5486400" cy="1371600"/>
+            <a:off x="6263640" y="2852928"/>
+            <a:ext cx="5486400" cy="1481328"/>
           </a:xfrm>
           <a:prstGeom prst="rect">
             <a:avLst/>
@@ -14038,7 +14038,7 @@
               <a:buChar char="▪"/>
             </a:pPr>
             <a:r>
-              <a:rPr lang="en-US" sz="1050" dirty="0">
+              <a:rPr lang="en-US" sz="1000" dirty="0">
                 <a:solidFill>
                   <a:srgbClr val="262626"/>
                 </a:solidFill>
@@ -14046,9 +14046,9 @@
                 <a:ea typeface="Malgun Gothic" pitchFamily="34" charset="-122"/>
                 <a:cs typeface="Malgun Gothic" pitchFamily="34" charset="-120"/>
               </a:rPr>
-              <a:t>카리브해 — 연중 안정적인 북동무역풍(045~090°) + Caribbean Low-Level Jet</a:t>
+              <a:t>카리브해 — 연중 안정적인 북동무역풍(045~090°) + Caribbean Low-Level Jet, 항로 실측 풍황(U10 7.0 m/s)으로 계산</a:t>
             </a:r>
-            <a:endParaRPr lang="en-US" sz="1050" dirty="0"/>
+            <a:endParaRPr lang="en-US" sz="1000" dirty="0"/>
           </a:p>
           <a:p>
             <a:pPr marL="165100" indent="-165100">
@@ -14059,7 +14059,7 @@
               <a:buChar char="▪"/>
             </a:pPr>
             <a:r>
-              <a:rPr lang="en-US" sz="1050" dirty="0">
+              <a:rPr lang="en-US" sz="1000" dirty="0">
                 <a:solidFill>
                   <a:srgbClr val="262626"/>
                 </a:solidFill>
@@ -14067,9 +14067,9 @@
                 <a:ea typeface="Malgun Gothic" pitchFamily="34" charset="-122"/>
                 <a:cs typeface="Malgun Gothic" pitchFamily="34" charset="-120"/>
               </a:rPr>
-              <a:t>시야각 4.6° &lt; 5° (SOLAS V/22), 화물탱크 위험구역 이격 · 관통형 지지대 반영</a:t>
+              <a:t>실선·문헌 절감률 6.5~9.1%(Maersk Pelican · TR Lady · Aframax 해석)와 부합 — 약풍 항로 사례는 2%대</a:t>
             </a:r>
-            <a:endParaRPr lang="en-US" sz="1050" dirty="0"/>
+            <a:endParaRPr lang="en-US" sz="1000" dirty="0"/>
           </a:p>
           <a:p>
             <a:pPr marL="165100" indent="-165100">
@@ -14080,7 +14080,7 @@
               <a:buChar char="▪"/>
             </a:pPr>
             <a:r>
-              <a:rPr lang="en-US" sz="1050" dirty="0">
+              <a:rPr lang="en-US" sz="1000" dirty="0">
                 <a:solidFill>
                   <a:srgbClr val="262626"/>
                 </a:solidFill>
@@ -14088,9 +14088,30 @@
                 <a:ea typeface="Malgun Gothic" pitchFamily="34" charset="-122"/>
                 <a:cs typeface="Malgun Gothic" pitchFamily="34" charset="-120"/>
               </a:rPr>
-              <a:t>실선 실적(Maersk Pelican 8.2%, TR Lady 9.1%)과 부합하는 절감률</a:t>
+              <a:t>로터 구동전력 3기 정격 345 kW를 전부 차감해도 순절감 380 kW 이상 (NCR 4.6%)</a:t>
             </a:r>
-            <a:endParaRPr lang="en-US" sz="1050" dirty="0"/>
+            <a:endParaRPr lang="en-US" sz="1000" dirty="0"/>
+          </a:p>
+          <a:p>
+            <a:pPr marL="165100" indent="-165100">
+              <a:spcAft>
+                <a:spcPts val="700"/>
+              </a:spcAft>
+              <a:buSzPct val="100000"/>
+              <a:buChar char="▪"/>
+            </a:pPr>
+            <a:r>
+              <a:rPr lang="en-US" sz="1000" dirty="0">
+                <a:solidFill>
+                  <a:srgbClr val="262626"/>
+                </a:solidFill>
+                <a:latin typeface="Malgun Gothic" pitchFamily="34" charset="0"/>
+                <a:ea typeface="Malgun Gothic" pitchFamily="34" charset="-122"/>
+                <a:cs typeface="Malgun Gothic" pitchFamily="34" charset="-120"/>
+              </a:rPr>
+              <a:t>시야각 4.6° &lt; 5° (SOLAS V/22), 화물탱크 위험구역 이격 · 관통형 지지대 반영</a:t>
+            </a:r>
+            <a:endParaRPr lang="en-US" sz="1000" dirty="0"/>
           </a:p>
         </p:txBody>
       </p:sp>
@@ -14506,7 +14527,7 @@
               <a:buNone/>
             </a:pPr>
             <a:r>
-              <a:rPr lang="en-US" sz="1350" b="1" dirty="0">
+              <a:rPr lang="en-US" sz="1300" b="1" dirty="0">
                 <a:solidFill>
                   <a:srgbClr val="C00000"/>
                 </a:solidFill>
@@ -14514,9 +14535,9 @@
                 <a:ea typeface="Malgun Gothic" pitchFamily="34" charset="-122"/>
                 <a:cs typeface="Malgun Gothic" pitchFamily="34" charset="-120"/>
               </a:rPr>
-              <a:t>→  Attained EEDI 3.475 &lt; Required 3.568 — EEDI Phase 3 만족</a:t>
+              <a:t>→  Attained EEDI 3.475 &lt; Required 3.568 — Phase 3 만족</a:t>
             </a:r>
-            <a:endParaRPr lang="en-US" sz="1350" dirty="0"/>
+            <a:endParaRPr lang="en-US" sz="1300" dirty="0"/>
           </a:p>
         </p:txBody>
       </p:sp>
@@ -17235,7 +17256,7 @@
                 <a:gridCol w="2286000"/>
                 <a:gridCol w="3456432"/>
               </a:tblGrid>
-              <a:tr h="338328">
+              <a:tr h="301752">
                 <a:tc>
                   <a:txBody>
                     <a:bodyPr/>
@@ -17373,7 +17394,7 @@
                   </a:tcPr>
                 </a:tc>
               </a:tr>
-              <a:tr h="338328">
+              <a:tr h="301752">
                 <a:tc>
                   <a:txBody>
                     <a:bodyPr/>
@@ -17505,7 +17526,7 @@
                   </a:tcPr>
                 </a:tc>
               </a:tr>
-              <a:tr h="338328">
+              <a:tr h="301752">
                 <a:tc>
                   <a:txBody>
                     <a:bodyPr/>
@@ -17637,7 +17658,7 @@
                   </a:tcPr>
                 </a:tc>
               </a:tr>
-              <a:tr h="338328">
+              <a:tr h="301752">
                 <a:tc>
                   <a:txBody>
                     <a:bodyPr/>
@@ -17769,7 +17790,7 @@
                   </a:tcPr>
                 </a:tc>
               </a:tr>
-              <a:tr h="338328">
+              <a:tr h="301752">
                 <a:tc>
                   <a:txBody>
                     <a:bodyPr/>
@@ -17913,8 +17934,8 @@
         </p:nvSpPr>
         <p:spPr>
           <a:xfrm>
-            <a:off x="6035040" y="5303520"/>
-            <a:ext cx="5715000" cy="457200"/>
+            <a:off x="6035040" y="5074920"/>
+            <a:ext cx="5715000" cy="777240"/>
           </a:xfrm>
           <a:prstGeom prst="rect">
             <a:avLst/>
@@ -17934,7 +17955,7 @@
               <a:buChar char="▪"/>
             </a:pPr>
             <a:r>
-              <a:rPr lang="en-US" sz="1100" dirty="0">
+              <a:rPr lang="en-US" sz="1000" dirty="0">
                 <a:solidFill>
                   <a:srgbClr val="262626"/>
                 </a:solidFill>
@@ -17944,7 +17965,28 @@
               </a:rPr>
               <a:t>ICLL · SOLAS · MARPOL · IS Code · IMO 조종성 기준 및 CSR 구조 요건 전부 만족</a:t>
             </a:r>
-            <a:endParaRPr lang="en-US" sz="1100" dirty="0"/>
+            <a:endParaRPr lang="en-US" sz="1000" dirty="0"/>
+          </a:p>
+          <a:p>
+            <a:pPr marL="165100" indent="-165100">
+              <a:spcAft>
+                <a:spcPts val="700"/>
+              </a:spcAft>
+              <a:buSzPct val="100000"/>
+              <a:buChar char="▪"/>
+            </a:pPr>
+            <a:r>
+              <a:rPr lang="en-US" sz="1000" dirty="0">
+                <a:solidFill>
+                  <a:srgbClr val="262626"/>
+                </a:solidFill>
+                <a:latin typeface="Malgun Gothic" pitchFamily="34" charset="0"/>
+                <a:ea typeface="Malgun Gothic" pitchFamily="34" charset="-122"/>
+                <a:cs typeface="Malgun Gothic" pitchFamily="34" charset="-120"/>
+              </a:rPr>
+              <a:t>후속 과제 — 프로펠러 캐비테이션 정량 검토 · 로터세일 기초 구조 및 풍하중 조종성 · 적하지침서 기반 정수중 하중 확정</a:t>
+            </a:r>
+            <a:endParaRPr lang="en-US" sz="1000" dirty="0"/>
           </a:p>
         </p:txBody>
       </p:sp>

</xml_diff>